<commit_message>
Remove external evaluator — no evaluation role on this project
</commit_message>
<xml_diff>
--- a/grant/communications/2026-07-28-project-showcase.pptx
+++ b/grant/communications/2026-07-28-project-showcase.pptx
@@ -6810,77 +6810,6 @@
                 <a:latin typeface="Calibri"/>
               </a:rPr>
               <a:t>Compute + storage infrastructure for telemetry backend and dataset archiving</a:t>
-            </a:r>
-          </a:p>
-        </p:txBody>
-      </p:sp>
-      <p:sp>
-        <p:nvSpPr>
-          <p:cNvPr id="29" name="TextBox 28"/>
-          <p:cNvSpPr txBox="1"/>
-          <p:nvPr/>
-        </p:nvSpPr>
-        <p:spPr>
-          <a:xfrm>
-            <a:off x="7315200" y="3703320"/>
-            <a:ext cx="4297680" cy="320040"/>
-          </a:xfrm>
-          <a:prstGeom prst="rect">
-            <a:avLst/>
-          </a:prstGeom>
-          <a:noFill/>
-        </p:spPr>
-        <p:txBody>
-          <a:bodyPr wrap="square">
-            <a:spAutoFit/>
-          </a:bodyPr>
-          <a:lstStyle/>
-          <a:p>
-            <a:pPr algn="l"/>
-            <a:r>
-              <a:rPr sz="1100" b="1">
-                <a:solidFill>
-                  <a:srgbClr val="1E407C"/>
-                </a:solidFill>
-                <a:latin typeface="Calibri"/>
-              </a:rPr>
-              <a:t>E.B. Howard Consultants
-(Christine Howard)</a:t>
-            </a:r>
-          </a:p>
-        </p:txBody>
-      </p:sp>
-      <p:sp>
-        <p:nvSpPr>
-          <p:cNvPr id="30" name="TextBox 29"/>
-          <p:cNvSpPr txBox="1"/>
-          <p:nvPr/>
-        </p:nvSpPr>
-        <p:spPr>
-          <a:xfrm>
-            <a:off x="7315200" y="4005072"/>
-            <a:ext cx="4297680" cy="502920"/>
-          </a:xfrm>
-          <a:prstGeom prst="rect">
-            <a:avLst/>
-          </a:prstGeom>
-          <a:noFill/>
-        </p:spPr>
-        <p:txBody>
-          <a:bodyPr wrap="square">
-            <a:spAutoFit/>
-          </a:bodyPr>
-          <a:lstStyle/>
-          <a:p>
-            <a:pPr algn="l"/>
-            <a:r>
-              <a:rPr sz="1000" b="0">
-                <a:solidFill>
-                  <a:srgbClr val="556570"/>
-                </a:solidFill>
-                <a:latin typeface="Calibri"/>
-              </a:rPr>
-              <a:t>Independent external evaluation throughout the grant period</a:t>
             </a:r>
           </a:p>
         </p:txBody>

</xml_diff>